<commit_message>
docs: finalize presentation review packet
</commit_message>
<xml_diff>
--- a/presentation/predictor1-final-project.pptx
+++ b/presentation/predictor1-final-project.pptx
@@ -2,21 +2,21 @@
 <file path=ppt/presentation.xml><?xml version="1.0" encoding="utf-8"?>
 <p:presentation xmlns:p="http://schemas.openxmlformats.org/presentationml/2006/main">
   <p:sldMasterIdLst>
-    <p:sldMasterId xmlns:r="http://schemas.openxmlformats.org/officeDocument/2006/relationships" id="2147483648" r:id="R4faef6b89c2e433f"/>
+    <p:sldMasterId xmlns:r="http://schemas.openxmlformats.org/officeDocument/2006/relationships" id="2147483648" r:id="Rabde874c3b444e19"/>
   </p:sldMasterIdLst>
   <p:notesMasterIdLst>
-    <p:notesMasterId xmlns:r="http://schemas.openxmlformats.org/officeDocument/2006/relationships" r:id="Ra7a19a227c0b4182"/>
+    <p:notesMasterId xmlns:r="http://schemas.openxmlformats.org/officeDocument/2006/relationships" r:id="R8b38503e92d448f4"/>
   </p:notesMasterIdLst>
   <p:sldIdLst>
-    <p:sldId xmlns:r="http://schemas.openxmlformats.org/officeDocument/2006/relationships" id="256" r:id="R2142d97ba70e4bee"/>
-    <p:sldId xmlns:r="http://schemas.openxmlformats.org/officeDocument/2006/relationships" id="257" r:id="R8134bb3ba9834921"/>
-    <p:sldId xmlns:r="http://schemas.openxmlformats.org/officeDocument/2006/relationships" id="258" r:id="Re13fdff2e6d04c8f"/>
-    <p:sldId xmlns:r="http://schemas.openxmlformats.org/officeDocument/2006/relationships" id="259" r:id="R7e91e60cf1ff4bc4"/>
-    <p:sldId xmlns:r="http://schemas.openxmlformats.org/officeDocument/2006/relationships" id="260" r:id="R10c3295ce8bf48ac"/>
-    <p:sldId xmlns:r="http://schemas.openxmlformats.org/officeDocument/2006/relationships" id="261" r:id="R8908db5ab9fb4b40"/>
-    <p:sldId xmlns:r="http://schemas.openxmlformats.org/officeDocument/2006/relationships" id="262" r:id="R0e092506611541f3"/>
-    <p:sldId xmlns:r="http://schemas.openxmlformats.org/officeDocument/2006/relationships" id="263" r:id="Rcb89adf5f79f4be0"/>
-    <p:sldId xmlns:r="http://schemas.openxmlformats.org/officeDocument/2006/relationships" id="264" r:id="Ra11728e02627411e"/>
+    <p:sldId xmlns:r="http://schemas.openxmlformats.org/officeDocument/2006/relationships" id="256" r:id="Rf72537b1d0404567"/>
+    <p:sldId xmlns:r="http://schemas.openxmlformats.org/officeDocument/2006/relationships" id="257" r:id="R80cec7d5ee38436c"/>
+    <p:sldId xmlns:r="http://schemas.openxmlformats.org/officeDocument/2006/relationships" id="258" r:id="Rc26d2aa33aab4564"/>
+    <p:sldId xmlns:r="http://schemas.openxmlformats.org/officeDocument/2006/relationships" id="259" r:id="R94b713f326364134"/>
+    <p:sldId xmlns:r="http://schemas.openxmlformats.org/officeDocument/2006/relationships" id="260" r:id="R039bfce4fc5540dc"/>
+    <p:sldId xmlns:r="http://schemas.openxmlformats.org/officeDocument/2006/relationships" id="261" r:id="R2b6c6ab3192a4964"/>
+    <p:sldId xmlns:r="http://schemas.openxmlformats.org/officeDocument/2006/relationships" id="262" r:id="Rbd854a5b43d64779"/>
+    <p:sldId xmlns:r="http://schemas.openxmlformats.org/officeDocument/2006/relationships" id="263" r:id="Re2fdd08759774ec8"/>
+    <p:sldId xmlns:r="http://schemas.openxmlformats.org/officeDocument/2006/relationships" id="264" r:id="R0b772c02b9c147ff"/>
   </p:sldIdLst>
   <p:sldSz cx="12192000" cy="6858000"/>
   <p:notesSz cx="6858000" cy="9144000"/>
@@ -1373,7 +1373,7 @@
   </p:cSld>
   <p:clrMap bg1="lt1" tx1="dk1" bg2="lt2" tx2="dk2" accent1="accent1" accent2="accent2" accent3="accent3" accent4="accent4" accent5="accent5" accent6="accent6" hlink="hlink" folHlink="folHlink"/>
   <p:sldLayoutIdLst>
-    <p:sldLayoutId xmlns:r="http://schemas.openxmlformats.org/officeDocument/2006/relationships" id="2147483649" r:id="Rb87f01ea1def4814"/>
+    <p:sldLayoutId xmlns:r="http://schemas.openxmlformats.org/officeDocument/2006/relationships" id="2147483649" r:id="R20abd19373cc40fb"/>
   </p:sldLayoutIdLst>
   <p:txStyles>
     <p:titleStyle>
@@ -3195,14 +3195,14 @@
       </p:sp>
       <p:pic>
         <p:nvPicPr>
-          <p:cNvPr id="11" name=""/>
+          <p:cNvPr id="13" name=""/>
           <p:cNvPicPr>
             <a:picLocks xmlns:a="http://schemas.openxmlformats.org/drawingml/2006/main" noChangeAspect="1"/>
           </p:cNvPicPr>
           <p:nvPr/>
         </p:nvPicPr>
         <p:blipFill>
-          <a:blip xmlns:r="http://schemas.openxmlformats.org/officeDocument/2006/relationships" xmlns:a="http://schemas.openxmlformats.org/drawingml/2006/main" r:embed="Re6e6044cce194ee2"/>
+          <a:blip xmlns:r="http://schemas.openxmlformats.org/officeDocument/2006/relationships" xmlns:a="http://schemas.openxmlformats.org/drawingml/2006/main" r:embed="Rc6396e9a1adb4f08"/>
           <a:stretch xmlns:a="http://schemas.openxmlformats.org/drawingml/2006/main"/>
         </p:blipFill>
         <p:spPr>
@@ -5881,14 +5881,14 @@
       </p:sp>
       <p:pic>
         <p:nvPicPr>
-          <p:cNvPr id="11" name=""/>
+          <p:cNvPr id="13" name=""/>
           <p:cNvPicPr>
             <a:picLocks xmlns:a="http://schemas.openxmlformats.org/drawingml/2006/main" noChangeAspect="1"/>
           </p:cNvPicPr>
           <p:nvPr/>
         </p:nvPicPr>
         <p:blipFill>
-          <a:blip xmlns:r="http://schemas.openxmlformats.org/officeDocument/2006/relationships" xmlns:a="http://schemas.openxmlformats.org/drawingml/2006/main" r:embed="R278f0266982e4a50"/>
+          <a:blip xmlns:r="http://schemas.openxmlformats.org/officeDocument/2006/relationships" xmlns:a="http://schemas.openxmlformats.org/drawingml/2006/main" r:embed="R99712325b3da404a"/>
           <a:stretch xmlns:a="http://schemas.openxmlformats.org/drawingml/2006/main"/>
         </p:blipFill>
         <p:spPr>
@@ -6498,7 +6498,7 @@
                 <a:ea typeface="Arial"/>
                 <a:cs typeface="Arial"/>
               </a:rPr>
-              <a:t>חי. ספורט בספק תלויות אינן הבדיקות ב־27.8.2026; מקומית נמדדו הספירות</a:t>
+              <a:t>Final-SHA evidence only • CI does not depend on a live Sports provider</a:t>
             </a:r>
           </a:p>
         </p:txBody>
@@ -6591,7 +6591,7 @@
                 <a:ea typeface="Arial"/>
                 <a:cs typeface="Arial"/>
               </a:rPr>
-              <a:t>627/627</a:t>
+              <a:t>RULES</a:t>
             </a:r>
           </a:p>
         </p:txBody>
@@ -6680,7 +6680,7 @@
                 <a:ea typeface="Arial"/>
                 <a:cs typeface="Arial"/>
               </a:rPr>
-              <a:t>48 קבצים</a:t>
+              <a:t>validation + domain</a:t>
             </a:r>
           </a:p>
         </p:txBody>
@@ -6773,7 +6773,7 @@
                 <a:ea typeface="Arial"/>
                 <a:cs typeface="Arial"/>
               </a:rPr>
-              <a:t>1443/1443</a:t>
+              <a:t>DATA</a:t>
             </a:r>
           </a:p>
         </p:txBody>
@@ -6862,7 +6862,7 @@
                 <a:ea typeface="Arial"/>
                 <a:cs typeface="Arial"/>
               </a:rPr>
-              <a:t>30 קבצים</a:t>
+              <a:t>RLS + atomicity</a:t>
             </a:r>
           </a:p>
         </p:txBody>
@@ -6955,7 +6955,7 @@
                 <a:ea typeface="Arial"/>
                 <a:cs typeface="Arial"/>
               </a:rPr>
-              <a:t>28/28</a:t>
+              <a:t>FLOWS</a:t>
             </a:r>
           </a:p>
         </p:txBody>
@@ -7044,7 +7044,7 @@
                 <a:ea typeface="Arial"/>
                 <a:cs typeface="Arial"/>
               </a:rPr>
-              <a:t>Desktop + Pixel 5</a:t>
+              <a:t>lifecycle + cross-user</a:t>
             </a:r>
           </a:p>
         </p:txBody>
@@ -8286,7 +8286,7 @@
                 <a:latin typeface="Arial"/>
                 <a:ea typeface="Arial"/>
                 <a:cs typeface="Arial"/>
-                <a:hlinkClick xmlns:r="http://schemas.openxmlformats.org/officeDocument/2006/relationships" r:id="R63c60d65947a492a"/>
+                <a:hlinkClick xmlns:r="http://schemas.openxmlformats.org/officeDocument/2006/relationships" r:id="R46a5e2486ec34c56"/>
               </a:rPr>
               <a:t>Production Demo</a:t>
             </a:r>
@@ -8314,7 +8314,7 @@
                 <a:latin typeface="Arial"/>
                 <a:ea typeface="Arial"/>
                 <a:cs typeface="Arial"/>
-                <a:hlinkClick xmlns:r="http://schemas.openxmlformats.org/officeDocument/2006/relationships" r:id="R954f62eada5d4faa"/>
+                <a:hlinkClick xmlns:r="http://schemas.openxmlformats.org/officeDocument/2006/relationships" r:id="R3328295366334335"/>
               </a:rPr>
               <a:t>GitHub repository</a:t>
             </a:r>

</xml_diff>

<commit_message>
docs(presentation): refresh final measured counts
</commit_message>
<xml_diff>
--- a/presentation/predictor1-final-project.pptx
+++ b/presentation/predictor1-final-project.pptx
@@ -626,7 +626,7 @@
             </a:r>
             <a:r>
               <a:rPr lang="en-US"/>
-              <a:t xml:space="preserve">639 </a:t>
+              <a:t xml:space="preserve">641 </a:t>
             </a:r>
             <a:r>
               <a:rPr lang="he-IL"/>
@@ -634,7 +634,7 @@
             </a:r>
             <a:r>
               <a:rPr lang="en-US"/>
-              <a:t xml:space="preserve">31 </a:t>
+              <a:t xml:space="preserve">32 </a:t>
             </a:r>
             <a:r>
               <a:rPr lang="he-IL"/>
@@ -650,7 +650,7 @@
             </a:r>
             <a:r>
               <a:rPr lang="en-US"/>
-              <a:t xml:space="preserve">1,496 </a:t>
+              <a:t xml:space="preserve">1,502 </a:t>
             </a:r>
             <a:r>
               <a:rPr lang="he-IL"/>
@@ -670,7 +670,7 @@
             </a:r>
             <a:r>
               <a:rPr lang="he-IL"/>
-              <a:t>נצפו בהרצה הסופית.</a:t>
+              <a:t>נצפו על מועמד המסירה.</a:t>
             </a:r>
             <a:r>
               <a:rPr lang="he-IL"/>
@@ -4231,7 +4231,7 @@
                 <a:ea typeface="Arial"/>
                 <a:cs typeface="Arial"/>
               </a:rPr>
-              <a:t>50 / 639</a:t>
+              <a:t>50 / 641</a:t>
             </a:r>
           </a:p>
         </p:txBody>
@@ -4495,7 +4495,7 @@
                 <a:ea typeface="Arial"/>
                 <a:cs typeface="Arial"/>
               </a:rPr>
-              <a:t>31 / 1,496</a:t>
+              <a:t>32 / 1,502</a:t>
             </a:r>
           </a:p>
         </p:txBody>

</xml_diff>